<commit_message>
fix: remove Definition E labels, use 制吐薬（狭義）/narrow definition
- Replace all '定義E'/'Definition E' with '制吐薬（狭義）' in manuscript
- Replace all '定義A'/'Definition A' with '制吐薬（広義）' in manuscript
- Update figure titles: 'Broad vs Narrow Antiemetic Definition'
- Update PPTX slide titles accordingly
- Fix bug #1: use pre-exclusion counts (n_single_raw/n_twin_raw) in manuscript
- Fix bug #2: add else:raise for reduced model fallback

Co-Authored-By: Tatsuki Onishi <bougtoir@gmail.com>
</commit_message>
<xml_diff>
--- a/yago_ionv/figures_ionv_e.pptx
+++ b/yago_ionv/figures_ionv_e.pptx
@@ -3118,7 +3118,7 @@
               <a:defRPr sz="2400" b="1"/>
             </a:pPr>
             <a:r>
-              <a:t>Fig. 1: IONV Rates — Protocol (A) vs 5-HT3 (E)</a:t>
+              <a:t>Fig. 1: IONV Rates — Broad vs Narrow Antiemetic Definition</a:t>
             </a:r>
           </a:p>
         </p:txBody>
@@ -3192,7 +3192,7 @@
               <a:defRPr sz="2400" b="1"/>
             </a:pPr>
             <a:r>
-              <a:t>Fig. 2: Logistic Regression — 5-HT3 Use (Def E Primary)</a:t>
+              <a:t>Fig. 2: Logistic Regression — 5-HT3 Antagonist Use (Narrow Definition)</a:t>
             </a:r>
           </a:p>
         </p:txBody>
@@ -3266,7 +3266,7 @@
               <a:defRPr sz="2400" b="1"/>
             </a:pPr>
             <a:r>
-              <a:t>Fig. 3: Covariate Sensitivity Analysis (Def E Primary)</a:t>
+              <a:t>Fig. 3: Covariate Sensitivity Analysis (5-HT3 Antagonist)</a:t>
             </a:r>
           </a:p>
         </p:txBody>
@@ -3340,7 +3340,7 @@
               <a:defRPr sz="2400" b="1"/>
             </a:pPr>
             <a:r>
-              <a:t>Fig. 4: Twin Effect — Protocol vs 5-HT3 Definition</a:t>
+              <a:t>Fig. 4: Twin Effect — Broad vs Narrow Antiemetic Definition</a:t>
             </a:r>
           </a:p>
         </p:txBody>

</xml_diff>